<commit_message>
docs: agregar liquidación de tramo al flujo end to end
</commit_message>
<xml_diff>
--- a/docs/Paul - Flujo end to end.pptx
+++ b/docs/Paul - Flujo end to end.pptx
@@ -10,6 +10,7 @@
     <p:sldId id="258" r:id="rId9"/>
     <p:sldId id="259" r:id="rId10"/>
     <p:sldId id="260" r:id="rId11"/>
+    <p:sldId id="261" r:id="rId12"/>
   </p:sldIdLst>
   <p:sldSz cx="12191695" cy="6858000" type="screen4x3"/>
   <p:notesSz cx="6858000" cy="9144000"/>
@@ -3726,6 +3727,128 @@
           <a:xfrm>
             <a:off x="563727" y="1234440"/>
             <a:ext cx="11064240" cy="2268692"/>
+          </a:xfrm>
+          <a:prstGeom prst="rect">
+            <a:avLst/>
+          </a:prstGeom>
+        </p:spPr>
+      </p:pic>
+    </p:spTree>
+  </p:cSld>
+  <p:clrMapOvr>
+    <a:masterClrMapping/>
+  </p:clrMapOvr>
+</p:sld>
+</file>
+
+<file path=ppt/slides/slide6.xml><?xml version="1.0" encoding="utf-8"?>
+<p:sld xmlns:a="http://schemas.openxmlformats.org/drawingml/2006/main" xmlns:p="http://schemas.openxmlformats.org/presentationml/2006/main" xmlns:r="http://schemas.openxmlformats.org/officeDocument/2006/relationships">
+  <p:cSld>
+    <p:spTree>
+      <p:nvGrpSpPr>
+        <p:cNvPr id="1" name=""/>
+        <p:cNvGrpSpPr/>
+        <p:nvPr/>
+      </p:nvGrpSpPr>
+      <p:grpSpPr/>
+      <p:sp>
+        <p:nvSpPr>
+          <p:cNvPr id="2" name="TextBox 1"/>
+          <p:cNvSpPr txBox="1"/>
+          <p:nvPr/>
+        </p:nvSpPr>
+        <p:spPr>
+          <a:xfrm>
+            <a:off x="548640" y="320040"/>
+            <a:ext cx="11064240" cy="731520"/>
+          </a:xfrm>
+          <a:prstGeom prst="rect">
+            <a:avLst/>
+          </a:prstGeom>
+          <a:noFill/>
+        </p:spPr>
+        <p:txBody>
+          <a:bodyPr wrap="none">
+            <a:spAutoFit/>
+          </a:bodyPr>
+          <a:lstStyle/>
+          <a:p>
+            <a:pPr>
+              <a:defRPr sz="2400" b="1">
+                <a:solidFill>
+                  <a:srgbClr val="151A24"/>
+                </a:solidFill>
+                <a:latin typeface="Calibri"/>
+              </a:defRPr>
+            </a:pPr>
+            <a:r>
+              <a:t>5. Liquidacion de tramo: pago real y quema de fracciones</a:t>
+            </a:r>
+          </a:p>
+        </p:txBody>
+      </p:sp>
+      <p:sp>
+        <p:nvSpPr>
+          <p:cNvPr id="3" name="Rectangle 2"/>
+          <p:cNvSpPr/>
+          <p:nvPr/>
+        </p:nvSpPr>
+        <p:spPr>
+          <a:xfrm>
+            <a:off x="548640" y="1005840"/>
+            <a:ext cx="11064240" cy="25400"/>
+          </a:xfrm>
+          <a:prstGeom prst="rect">
+            <a:avLst/>
+          </a:prstGeom>
+          <a:solidFill>
+            <a:srgbClr val="0F6E56"/>
+          </a:solidFill>
+          <a:ln>
+            <a:noFill/>
+          </a:ln>
+          <a:effectLst/>
+        </p:spPr>
+        <p:style>
+          <a:lnRef idx="1">
+            <a:schemeClr val="accent1"/>
+          </a:lnRef>
+          <a:fillRef idx="3">
+            <a:schemeClr val="accent1"/>
+          </a:fillRef>
+          <a:effectRef idx="2">
+            <a:schemeClr val="accent1"/>
+          </a:effectRef>
+          <a:fontRef idx="minor">
+            <a:schemeClr val="lt1"/>
+          </a:fontRef>
+        </p:style>
+        <p:txBody>
+          <a:bodyPr rtlCol="0" anchor="ctr"/>
+          <a:lstStyle/>
+          <a:p>
+            <a:pPr algn="ctr"/>
+          </a:p>
+        </p:txBody>
+      </p:sp>
+      <p:pic>
+        <p:nvPicPr>
+          <p:cNvPr id="4" name="Picture 3" descr="proceso_5.png"/>
+          <p:cNvPicPr>
+            <a:picLocks noChangeAspect="1"/>
+          </p:cNvPicPr>
+          <p:nvPr/>
+        </p:nvPicPr>
+        <p:blipFill>
+          <a:blip r:embed="rId2"/>
+          <a:stretch>
+            <a:fillRect/>
+          </a:stretch>
+        </p:blipFill>
+        <p:spPr>
+          <a:xfrm>
+            <a:off x="563727" y="1234440"/>
+            <a:ext cx="11064240" cy="2577690"/>
           </a:xfrm>
           <a:prstGeom prst="rect">
             <a:avLst/>

</xml_diff>